<commit_message>
docs(presentations): polish jira-coding-agent deck — fix inactive text colors and wording
- Replace #1c1c1c with #666666 for all inactive items (slides 9-12, 15-18, 20, 23-28)
- Expand "PR" → "Pull Request" across all slides
- "Machine running" → "Local machine running"
- "Dev stays free" → "Developer barely waiting"
- "Transitions to" → "Transition to" (slide 18)

Co-Authored-By: Claude Sonnet 4.6 <noreply@anthropic.com>
</commit_message>
<xml_diff>
--- a/docs/presentations/2026-06-15-jira-coding-agent.pptx
+++ b/docs/presentations/2026-06-15-jira-coding-agent.pptx
@@ -5569,7 +5569,7 @@
                 <a:latin typeface="Calibri"/>
                 <a:ea typeface="Calibri"/>
               </a:rPr>
-              <a:t>From ticket to PR</a:t>
+              <a:t>From ticket to Pull Request</a:t>
             </a:r>
             <a:endParaRPr b="0" lang="pt-BR" sz="3800" spc="-1" strike="noStrike">
               <a:solidFill>
@@ -5669,7 +5669,7 @@
             <a:r>
               <a:rPr b="0" lang="en-US" sz="1100" spc="-1" strike="noStrike">
                 <a:solidFill>
-                  <a:srgbClr val="1c1c1c"/>
+                  <a:srgbClr val="666666"/>
                 </a:solidFill>
                 <a:latin typeface="Calibri"/>
                 <a:ea typeface="Calibri"/>
@@ -5726,7 +5726,7 @@
             <a:r>
               <a:rPr b="0" lang="en-US" sz="1600" spc="-1" strike="noStrike">
                 <a:solidFill>
-                  <a:srgbClr val="1c1c1c"/>
+                  <a:srgbClr val="666666"/>
                 </a:solidFill>
                 <a:latin typeface="Calibri"/>
                 <a:ea typeface="Calibri"/>
@@ -5831,7 +5831,7 @@
             <a:r>
               <a:rPr b="0" lang="en-US" sz="1100" spc="-1" strike="noStrike">
                 <a:solidFill>
-                  <a:srgbClr val="1c1c1c"/>
+                  <a:srgbClr val="666666"/>
                 </a:solidFill>
                 <a:latin typeface="Calibri"/>
                 <a:ea typeface="Calibri"/>
@@ -5857,7 +5857,7 @@
             <a:r>
               <a:rPr b="0" lang="en-US" sz="1100" spc="-1" strike="noStrike">
                 <a:solidFill>
-                  <a:srgbClr val="1c1c1c"/>
+                  <a:srgbClr val="666666"/>
                 </a:solidFill>
                 <a:latin typeface="Calibri"/>
                 <a:ea typeface="Calibri"/>
@@ -6177,7 +6177,7 @@
                 <a:latin typeface="Calibri"/>
                 <a:ea typeface="Calibri"/>
               </a:rPr>
-              <a:t>From ticket to PR</a:t>
+              <a:t>From ticket to Pull Request</a:t>
             </a:r>
             <a:endParaRPr b="0" lang="pt-BR" sz="3800" spc="-1" strike="noStrike">
               <a:solidFill>
@@ -6277,7 +6277,7 @@
             <a:r>
               <a:rPr b="0" lang="en-US" sz="1100" spc="-1" strike="noStrike">
                 <a:solidFill>
-                  <a:srgbClr val="1c1c1c"/>
+                  <a:srgbClr val="666666"/>
                 </a:solidFill>
                 <a:latin typeface="Calibri"/>
                 <a:ea typeface="Calibri"/>
@@ -6334,7 +6334,7 @@
             <a:r>
               <a:rPr b="0" lang="en-US" sz="1600" spc="-1" strike="noStrike">
                 <a:solidFill>
-                  <a:srgbClr val="1c1c1c"/>
+                  <a:srgbClr val="666666"/>
                 </a:solidFill>
                 <a:latin typeface="Calibri"/>
                 <a:ea typeface="Calibri"/>
@@ -6439,7 +6439,7 @@
             <a:r>
               <a:rPr b="0" lang="en-US" sz="1100" spc="-1" strike="noStrike">
                 <a:solidFill>
-                  <a:srgbClr val="1c1c1c"/>
+                  <a:srgbClr val="666666"/>
                 </a:solidFill>
                 <a:latin typeface="Calibri"/>
                 <a:ea typeface="Calibri"/>
@@ -6465,7 +6465,7 @@
             <a:r>
               <a:rPr b="0" lang="en-US" sz="1100" spc="-1" strike="noStrike">
                 <a:solidFill>
-                  <a:srgbClr val="1c1c1c"/>
+                  <a:srgbClr val="666666"/>
                 </a:solidFill>
                 <a:latin typeface="Calibri"/>
                 <a:ea typeface="Calibri"/>
@@ -6522,7 +6522,7 @@
             <a:r>
               <a:rPr b="0" lang="en-US" sz="1600" spc="-1" strike="noStrike">
                 <a:solidFill>
-                  <a:srgbClr val="1c1c1c"/>
+                  <a:srgbClr val="666666"/>
                 </a:solidFill>
                 <a:latin typeface="Calibri"/>
                 <a:ea typeface="Calibri"/>
@@ -6627,7 +6627,7 @@
             <a:r>
               <a:rPr b="0" lang="en-US" sz="1100" spc="-1" strike="noStrike">
                 <a:solidFill>
-                  <a:srgbClr val="1c1c1c"/>
+                  <a:srgbClr val="666666"/>
                 </a:solidFill>
                 <a:latin typeface="Calibri"/>
                 <a:ea typeface="Calibri"/>
@@ -6795,7 +6795,7 @@
                 <a:latin typeface="Calibri"/>
                 <a:ea typeface="Calibri"/>
               </a:rPr>
-              <a:t>PR</a:t>
+              <a:t>Pull Request</a:t>
             </a:r>
             <a:endParaRPr b="0" lang="pt-BR" sz="1100" spc="-1" strike="noStrike">
               <a:solidFill>
@@ -6947,7 +6947,7 @@
                 <a:latin typeface="Calibri"/>
                 <a:ea typeface="Calibri"/>
               </a:rPr>
-              <a:t>From ticket to PR</a:t>
+              <a:t>From ticket to Pull Request</a:t>
             </a:r>
             <a:endParaRPr b="0" lang="pt-BR" sz="3800" spc="-1" strike="noStrike">
               <a:solidFill>
@@ -7047,7 +7047,7 @@
             <a:r>
               <a:rPr b="0" lang="en-US" sz="1100" spc="-1" strike="noStrike">
                 <a:solidFill>
-                  <a:srgbClr val="1c1c1c"/>
+                  <a:srgbClr val="666666"/>
                 </a:solidFill>
                 <a:latin typeface="Calibri"/>
                 <a:ea typeface="Calibri"/>
@@ -7104,7 +7104,7 @@
             <a:r>
               <a:rPr b="0" lang="en-US" sz="1600" spc="-1" strike="noStrike">
                 <a:solidFill>
-                  <a:srgbClr val="1c1c1c"/>
+                  <a:srgbClr val="666666"/>
                 </a:solidFill>
                 <a:latin typeface="Calibri"/>
                 <a:ea typeface="Calibri"/>
@@ -7209,7 +7209,7 @@
             <a:r>
               <a:rPr b="0" lang="en-US" sz="1100" spc="-1" strike="noStrike">
                 <a:solidFill>
-                  <a:srgbClr val="1c1c1c"/>
+                  <a:srgbClr val="666666"/>
                 </a:solidFill>
                 <a:latin typeface="Calibri"/>
                 <a:ea typeface="Calibri"/>
@@ -7235,7 +7235,7 @@
             <a:r>
               <a:rPr b="0" lang="en-US" sz="1100" spc="-1" strike="noStrike">
                 <a:solidFill>
-                  <a:srgbClr val="1c1c1c"/>
+                  <a:srgbClr val="666666"/>
                 </a:solidFill>
                 <a:latin typeface="Calibri"/>
                 <a:ea typeface="Calibri"/>
@@ -7292,7 +7292,7 @@
             <a:r>
               <a:rPr b="0" lang="en-US" sz="1600" spc="-1" strike="noStrike">
                 <a:solidFill>
-                  <a:srgbClr val="1c1c1c"/>
+                  <a:srgbClr val="666666"/>
                 </a:solidFill>
                 <a:latin typeface="Calibri"/>
                 <a:ea typeface="Calibri"/>
@@ -7397,7 +7397,7 @@
             <a:r>
               <a:rPr b="0" lang="en-US" sz="1100" spc="-1" strike="noStrike">
                 <a:solidFill>
-                  <a:srgbClr val="1c1c1c"/>
+                  <a:srgbClr val="666666"/>
                 </a:solidFill>
                 <a:latin typeface="Calibri"/>
                 <a:ea typeface="Calibri"/>
@@ -7454,7 +7454,7 @@
             <a:r>
               <a:rPr b="0" lang="en-US" sz="1600" spc="-1" strike="noStrike">
                 <a:solidFill>
-                  <a:srgbClr val="1c1c1c"/>
+                  <a:srgbClr val="666666"/>
                 </a:solidFill>
                 <a:latin typeface="Calibri"/>
                 <a:ea typeface="Calibri"/>
@@ -7559,12 +7559,12 @@
             <a:r>
               <a:rPr b="0" lang="en-US" sz="1100" spc="-1" strike="noStrike">
                 <a:solidFill>
-                  <a:srgbClr val="1c1c1c"/>
+                  <a:srgbClr val="666666"/>
                 </a:solidFill>
                 <a:latin typeface="Calibri"/>
                 <a:ea typeface="Calibri"/>
               </a:rPr>
-              <a:t>PR</a:t>
+              <a:t>Pull Request</a:t>
             </a:r>
             <a:endParaRPr b="0" lang="pt-BR" sz="1100" spc="-1" strike="noStrike">
               <a:solidFill>
@@ -8204,7 +8204,7 @@
             <a:r>
               <a:rPr b="0" lang="en-US" sz="2600" spc="-1" strike="noStrike">
                 <a:solidFill>
-                  <a:srgbClr val="1c1c1c"/>
+                  <a:srgbClr val="666666"/>
                 </a:solidFill>
                 <a:latin typeface="Calibri"/>
                 <a:ea typeface="Calibri"/>
@@ -8413,7 +8413,7 @@
             <a:r>
               <a:rPr b="0" lang="en-US" sz="2600" spc="-1" strike="noStrike">
                 <a:solidFill>
-                  <a:srgbClr val="1c1c1c"/>
+                  <a:srgbClr val="666666"/>
                 </a:solidFill>
                 <a:latin typeface="Calibri"/>
                 <a:ea typeface="Calibri"/>
@@ -8470,7 +8470,7 @@
             <a:r>
               <a:rPr b="0" lang="en-US" sz="2600" spc="-1" strike="noStrike">
                 <a:solidFill>
-                  <a:srgbClr val="1c1c1c"/>
+                  <a:srgbClr val="666666"/>
                 </a:solidFill>
                 <a:latin typeface="Calibri"/>
                 <a:ea typeface="Calibri"/>
@@ -8532,7 +8532,7 @@
                 <a:latin typeface="Calibri"/>
                 <a:ea typeface="Calibri"/>
               </a:rPr>
-              <a:t>3.  Opens the PR</a:t>
+              <a:t>3.  Opens the Pull Request</a:t>
             </a:r>
             <a:endParaRPr b="0" lang="pt-BR" sz="2600" spc="-1" strike="noStrike">
               <a:solidFill>
@@ -8679,7 +8679,7 @@
             <a:r>
               <a:rPr b="0" lang="en-US" sz="2600" spc="-1" strike="noStrike">
                 <a:solidFill>
-                  <a:srgbClr val="1c1c1c"/>
+                  <a:srgbClr val="666666"/>
                 </a:solidFill>
                 <a:latin typeface="Calibri"/>
                 <a:ea typeface="Calibri"/>
@@ -8736,7 +8736,7 @@
             <a:r>
               <a:rPr b="0" lang="en-US" sz="2600" spc="-1" strike="noStrike">
                 <a:solidFill>
-                  <a:srgbClr val="1c1c1c"/>
+                  <a:srgbClr val="666666"/>
                 </a:solidFill>
                 <a:latin typeface="Calibri"/>
                 <a:ea typeface="Calibri"/>
@@ -8793,12 +8793,12 @@
             <a:r>
               <a:rPr b="0" lang="en-US" sz="2600" spc="-1" strike="noStrike">
                 <a:solidFill>
-                  <a:srgbClr val="1c1c1c"/>
+                  <a:srgbClr val="666666"/>
                 </a:solidFill>
                 <a:latin typeface="Calibri"/>
                 <a:ea typeface="Calibri"/>
               </a:rPr>
-              <a:t>3.  Opens the PR</a:t>
+              <a:t>3.  Opens the Pull Request</a:t>
             </a:r>
             <a:endParaRPr b="0" lang="pt-BR" sz="2600" spc="-1" strike="noStrike">
               <a:solidFill>
@@ -9002,7 +9002,7 @@
             <a:r>
               <a:rPr b="0" lang="en-US" sz="2600" spc="-1" strike="noStrike">
                 <a:solidFill>
-                  <a:srgbClr val="1c1c1c"/>
+                  <a:srgbClr val="666666"/>
                 </a:solidFill>
                 <a:latin typeface="Calibri"/>
                 <a:ea typeface="Calibri"/>
@@ -9059,7 +9059,7 @@
             <a:r>
               <a:rPr b="0" lang="en-US" sz="2600" spc="-1" strike="noStrike">
                 <a:solidFill>
-                  <a:srgbClr val="1c1c1c"/>
+                  <a:srgbClr val="666666"/>
                 </a:solidFill>
                 <a:latin typeface="Calibri"/>
                 <a:ea typeface="Calibri"/>
@@ -9116,12 +9116,12 @@
             <a:r>
               <a:rPr b="0" lang="en-US" sz="2600" spc="-1" strike="noStrike">
                 <a:solidFill>
-                  <a:srgbClr val="1c1c1c"/>
+                  <a:srgbClr val="666666"/>
                 </a:solidFill>
                 <a:latin typeface="Calibri"/>
                 <a:ea typeface="Calibri"/>
               </a:rPr>
-              <a:t>3.  Opens the PR</a:t>
+              <a:t>3.  Opens the Pull Request</a:t>
             </a:r>
             <a:endParaRPr b="0" lang="pt-BR" sz="2600" spc="-1" strike="noStrike">
               <a:solidFill>
@@ -9173,7 +9173,7 @@
             <a:r>
               <a:rPr b="0" lang="en-US" sz="2600" spc="-1" strike="noStrike">
                 <a:solidFill>
-                  <a:srgbClr val="1c1c1c"/>
+                  <a:srgbClr val="666666"/>
                 </a:solidFill>
                 <a:latin typeface="Calibri"/>
                 <a:ea typeface="Calibri"/>
@@ -9235,7 +9235,7 @@
                 <a:latin typeface="Calibri"/>
                 <a:ea typeface="Calibri"/>
               </a:rPr>
-              <a:t>5.  Transitions to "In Review"</a:t>
+              <a:t>5.  Transition to "In Review"</a:t>
             </a:r>
             <a:endParaRPr b="0" lang="pt-BR" sz="2600" spc="-1" strike="noStrike">
               <a:solidFill>
@@ -9539,7 +9539,7 @@
                 <a:latin typeface="Calibri"/>
                 <a:ea typeface="Calibri"/>
               </a:rPr>
-              <a:t>From ticket to PR: delegating to an agent</a:t>
+              <a:t>From ticket to Pull Request: delegating to an agent</a:t>
             </a:r>
             <a:endParaRPr b="0" lang="pt-BR" sz="1800" spc="-1" strike="noStrike">
               <a:solidFill>
@@ -9686,7 +9686,7 @@
             <a:r>
               <a:rPr b="1" lang="en-US" sz="3800" spc="-1" strike="noStrike">
                 <a:solidFill>
-                  <a:srgbClr val="1c1c1c"/>
+                  <a:srgbClr val="666666"/>
                 </a:solidFill>
                 <a:latin typeface="Calibri"/>
                 <a:ea typeface="Calibri"/>
@@ -10199,7 +10199,7 @@
             <a:r>
               <a:rPr b="0" lang="en-US" sz="2200" spc="-1" strike="noStrike">
                 <a:solidFill>
-                  <a:srgbClr val="1c1c1c"/>
+                  <a:srgbClr val="666666"/>
                 </a:solidFill>
                 <a:latin typeface="Calibri"/>
                 <a:ea typeface="Calibri"/>
@@ -10408,7 +10408,7 @@
             <a:r>
               <a:rPr b="0" lang="en-US" sz="2200" spc="-1" strike="noStrike">
                 <a:solidFill>
-                  <a:srgbClr val="1c1c1c"/>
+                  <a:srgbClr val="666666"/>
                 </a:solidFill>
                 <a:latin typeface="Calibri"/>
                 <a:ea typeface="Calibri"/>
@@ -10465,7 +10465,7 @@
             <a:r>
               <a:rPr b="0" lang="en-US" sz="2200" spc="-1" strike="noStrike">
                 <a:solidFill>
-                  <a:srgbClr val="1c1c1c"/>
+                  <a:srgbClr val="666666"/>
                 </a:solidFill>
                 <a:latin typeface="Calibri"/>
                 <a:ea typeface="Calibri"/>
@@ -10674,7 +10674,7 @@
             <a:r>
               <a:rPr b="0" lang="en-US" sz="2200" spc="-1" strike="noStrike">
                 <a:solidFill>
-                  <a:srgbClr val="1c1c1c"/>
+                  <a:srgbClr val="666666"/>
                 </a:solidFill>
                 <a:latin typeface="Calibri"/>
                 <a:ea typeface="Calibri"/>
@@ -10731,7 +10731,7 @@
             <a:r>
               <a:rPr b="0" lang="en-US" sz="2200" spc="-1" strike="noStrike">
                 <a:solidFill>
-                  <a:srgbClr val="1c1c1c"/>
+                  <a:srgbClr val="666666"/>
                 </a:solidFill>
                 <a:latin typeface="Calibri"/>
                 <a:ea typeface="Calibri"/>
@@ -10788,7 +10788,7 @@
             <a:r>
               <a:rPr b="0" lang="en-US" sz="2200" spc="-1" strike="noStrike">
                 <a:solidFill>
-                  <a:srgbClr val="1c1c1c"/>
+                  <a:srgbClr val="666666"/>
                 </a:solidFill>
                 <a:latin typeface="Calibri"/>
                 <a:ea typeface="Calibri"/>
@@ -10997,7 +10997,7 @@
             <a:r>
               <a:rPr b="0" lang="en-US" sz="2200" spc="-1" strike="noStrike">
                 <a:solidFill>
-                  <a:srgbClr val="1c1c1c"/>
+                  <a:srgbClr val="666666"/>
                 </a:solidFill>
                 <a:latin typeface="Calibri"/>
                 <a:ea typeface="Calibri"/>
@@ -11054,7 +11054,7 @@
             <a:r>
               <a:rPr b="0" lang="en-US" sz="2200" spc="-1" strike="noStrike">
                 <a:solidFill>
-                  <a:srgbClr val="1c1c1c"/>
+                  <a:srgbClr val="666666"/>
                 </a:solidFill>
                 <a:latin typeface="Calibri"/>
                 <a:ea typeface="Calibri"/>
@@ -11111,7 +11111,7 @@
             <a:r>
               <a:rPr b="0" lang="en-US" sz="2200" spc="-1" strike="noStrike">
                 <a:solidFill>
-                  <a:srgbClr val="1c1c1c"/>
+                  <a:srgbClr val="666666"/>
                 </a:solidFill>
                 <a:latin typeface="Calibri"/>
                 <a:ea typeface="Calibri"/>
@@ -11168,7 +11168,7 @@
             <a:r>
               <a:rPr b="0" lang="en-US" sz="2200" spc="-1" strike="noStrike">
                 <a:solidFill>
-                  <a:srgbClr val="1c1c1c"/>
+                  <a:srgbClr val="666666"/>
                 </a:solidFill>
                 <a:latin typeface="Calibri"/>
                 <a:ea typeface="Calibri"/>
@@ -11377,7 +11377,7 @@
             <a:r>
               <a:rPr b="0" lang="en-US" sz="2200" spc="-1" strike="noStrike">
                 <a:solidFill>
-                  <a:srgbClr val="1c1c1c"/>
+                  <a:srgbClr val="666666"/>
                 </a:solidFill>
                 <a:latin typeface="Calibri"/>
                 <a:ea typeface="Calibri"/>
@@ -11434,7 +11434,7 @@
             <a:r>
               <a:rPr b="0" lang="en-US" sz="2200" spc="-1" strike="noStrike">
                 <a:solidFill>
-                  <a:srgbClr val="1c1c1c"/>
+                  <a:srgbClr val="666666"/>
                 </a:solidFill>
                 <a:latin typeface="Calibri"/>
                 <a:ea typeface="Calibri"/>
@@ -11491,7 +11491,7 @@
             <a:r>
               <a:rPr b="0" lang="en-US" sz="2200" spc="-1" strike="noStrike">
                 <a:solidFill>
-                  <a:srgbClr val="1c1c1c"/>
+                  <a:srgbClr val="666666"/>
                 </a:solidFill>
                 <a:latin typeface="Calibri"/>
                 <a:ea typeface="Calibri"/>
@@ -11548,7 +11548,7 @@
             <a:r>
               <a:rPr b="0" lang="en-US" sz="2200" spc="-1" strike="noStrike">
                 <a:solidFill>
-                  <a:srgbClr val="1c1c1c"/>
+                  <a:srgbClr val="666666"/>
                 </a:solidFill>
                 <a:latin typeface="Calibri"/>
                 <a:ea typeface="Calibri"/>
@@ -11605,7 +11605,7 @@
             <a:r>
               <a:rPr b="0" lang="en-US" sz="2200" spc="-1" strike="noStrike">
                 <a:solidFill>
-                  <a:srgbClr val="1c1c1c"/>
+                  <a:srgbClr val="666666"/>
                 </a:solidFill>
                 <a:latin typeface="Calibri"/>
                 <a:ea typeface="Calibri"/>
@@ -11814,7 +11814,7 @@
             <a:r>
               <a:rPr b="0" lang="en-US" sz="2200" spc="-1" strike="noStrike">
                 <a:solidFill>
-                  <a:srgbClr val="1c1c1c"/>
+                  <a:srgbClr val="666666"/>
                 </a:solidFill>
                 <a:latin typeface="Calibri"/>
                 <a:ea typeface="Calibri"/>
@@ -11871,7 +11871,7 @@
             <a:r>
               <a:rPr b="0" lang="en-US" sz="2200" spc="-1" strike="noStrike">
                 <a:solidFill>
-                  <a:srgbClr val="1c1c1c"/>
+                  <a:srgbClr val="666666"/>
                 </a:solidFill>
                 <a:latin typeface="Calibri"/>
                 <a:ea typeface="Calibri"/>
@@ -11928,7 +11928,7 @@
             <a:r>
               <a:rPr b="0" lang="en-US" sz="2200" spc="-1" strike="noStrike">
                 <a:solidFill>
-                  <a:srgbClr val="1c1c1c"/>
+                  <a:srgbClr val="666666"/>
                 </a:solidFill>
                 <a:latin typeface="Calibri"/>
                 <a:ea typeface="Calibri"/>
@@ -11985,7 +11985,7 @@
             <a:r>
               <a:rPr b="0" lang="en-US" sz="2200" spc="-1" strike="noStrike">
                 <a:solidFill>
-                  <a:srgbClr val="1c1c1c"/>
+                  <a:srgbClr val="666666"/>
                 </a:solidFill>
                 <a:latin typeface="Calibri"/>
                 <a:ea typeface="Calibri"/>
@@ -12042,7 +12042,7 @@
             <a:r>
               <a:rPr b="0" lang="en-US" sz="2200" spc="-1" strike="noStrike">
                 <a:solidFill>
-                  <a:srgbClr val="1c1c1c"/>
+                  <a:srgbClr val="666666"/>
                 </a:solidFill>
                 <a:latin typeface="Calibri"/>
                 <a:ea typeface="Calibri"/>
@@ -12099,7 +12099,7 @@
             <a:r>
               <a:rPr b="0" lang="en-US" sz="2200" spc="-1" strike="noStrike">
                 <a:solidFill>
-                  <a:srgbClr val="1c1c1c"/>
+                  <a:srgbClr val="666666"/>
                 </a:solidFill>
                 <a:latin typeface="Calibri"/>
                 <a:ea typeface="Calibri"/>
@@ -12883,7 +12883,7 @@
                 <a:latin typeface="Calibri"/>
                 <a:ea typeface="Calibri"/>
               </a:rPr>
-              <a:t>Machine running</a:t>
+              <a:t>Local machine running</a:t>
             </a:r>
             <a:endParaRPr b="0" lang="pt-BR" sz="3000" spc="-1" strike="noStrike">
               <a:solidFill>
@@ -13149,7 +13149,7 @@
                 <a:latin typeface="Calibri"/>
                 <a:ea typeface="Calibri"/>
               </a:rPr>
-              <a:t>Machine running</a:t>
+              <a:t>Local machine running</a:t>
             </a:r>
             <a:endParaRPr b="0" lang="pt-BR" sz="3000" spc="-1" strike="noStrike">
               <a:solidFill>
@@ -13206,7 +13206,7 @@
                 <a:latin typeface="Calibri"/>
                 <a:ea typeface="Calibri"/>
               </a:rPr>
-              <a:t>Dev stays free</a:t>
+              <a:t>Developer barely waiting</a:t>
             </a:r>
             <a:endParaRPr b="0" lang="pt-BR" sz="3000" spc="-1" strike="noStrike">
               <a:solidFill>
@@ -13472,7 +13472,7 @@
                 <a:latin typeface="Calibri"/>
                 <a:ea typeface="Calibri"/>
               </a:rPr>
-              <a:t>Machine running</a:t>
+              <a:t>Local machine running</a:t>
             </a:r>
             <a:endParaRPr b="0" lang="pt-BR" sz="3000" spc="-1" strike="noStrike">
               <a:solidFill>
@@ -13529,7 +13529,7 @@
                 <a:latin typeface="Calibri"/>
                 <a:ea typeface="Calibri"/>
               </a:rPr>
-              <a:t>Dev stays free</a:t>
+              <a:t>Developer barely waiting</a:t>
             </a:r>
             <a:endParaRPr b="0" lang="pt-BR" sz="3000" spc="-1" strike="noStrike">
               <a:solidFill>
@@ -13738,7 +13738,7 @@
                 <a:latin typeface="Calibri"/>
                 <a:ea typeface="Calibri"/>
               </a:rPr>
-              <a:t>From ticket to PR</a:t>
+              <a:t>From ticket to Pull Request</a:t>
             </a:r>
             <a:endParaRPr b="0" lang="pt-BR" sz="3800" spc="-1" strike="noStrike">
               <a:solidFill>
@@ -13996,7 +13996,7 @@
                 <a:latin typeface="Calibri"/>
                 <a:ea typeface="Calibri"/>
               </a:rPr>
-              <a:t>From ticket to PR</a:t>
+              <a:t>From ticket to Pull Request</a:t>
             </a:r>
             <a:endParaRPr b="0" lang="pt-BR" sz="3800" spc="-1" strike="noStrike">
               <a:solidFill>
@@ -14096,7 +14096,7 @@
             <a:r>
               <a:rPr b="0" lang="en-US" sz="1100" spc="-1" strike="noStrike">
                 <a:solidFill>
-                  <a:srgbClr val="1c1c1c"/>
+                  <a:srgbClr val="666666"/>
                 </a:solidFill>
                 <a:latin typeface="Calibri"/>
                 <a:ea typeface="Calibri"/>

</xml_diff>